<commit_message>
updated debugger connection and ignore files
</commit_message>
<xml_diff>
--- a/1tops_soc/src/debugger/soc_debugger_architecture.pptx
+++ b/1tops_soc/src/debugger/soc_debugger_architecture.pptx
@@ -3460,7 +3460,7 @@
               </a:defRPr>
             </a:pPr>
             <a:r>
-              <a:t>UARTSin / UARTSout</a:t>
+              <a:t>2 Wires</a:t>
             </a:r>
           </a:p>
         </p:txBody>
@@ -3533,6 +3533,7 @@
             </a:r>
           </a:p>
           <a:p>
+            <a:br/>
             <a:pPr>
               <a:defRPr sz="1100">
                 <a:solidFill>
@@ -3541,7 +3542,27 @@
               </a:defRPr>
             </a:pPr>
             <a:r>
-              <a:t> • Uses Uncore 16550 UART • Direct internal streaming • Translates ADP text to AHB • Holds Pause Button: 'core_halt_o' • Controls AHB Master 1</a:t>
+              <a:t>• Listens on serial RX</a:t>
+            </a:r>
+            <a:br/>
+            <a:r>
+              <a:t>• Translates text to</a:t>
+            </a:r>
+            <a:br/>
+            <a:r>
+              <a:t>  bus commands</a:t>
+            </a:r>
+            <a:br/>
+            <a:r>
+              <a:t>• Holds Pause Button:</a:t>
+            </a:r>
+            <a:br/>
+            <a:r>
+              <a:t>  'core_halt_o'</a:t>
+            </a:r>
+            <a:br/>
+            <a:r>
+              <a:t>• Controls AHB Master 1</a:t>
             </a:r>
           </a:p>
         </p:txBody>
@@ -3991,6 +4012,7 @@
             </a:r>
           </a:p>
           <a:p>
+            <a:br/>
             <a:pPr>
               <a:defRPr sz="1000">
                 <a:solidFill>
@@ -3999,7 +4021,37 @@
               </a:defRPr>
             </a:pPr>
             <a:r>
-              <a:t> [ACCELERATOR] • 0x30000000 space • Product = 42 • Large 16MB window  [MAIN RAM] • Program variables  [PERIPHERALS] • 16550 UART (Console+Debug), Timers, GPIO</a:t>
+              <a:t>[ACCELERATOR]</a:t>
+            </a:r>
+            <a:br/>
+            <a:r>
+              <a:t>• 0x30000000 space</a:t>
+            </a:r>
+            <a:br/>
+            <a:r>
+              <a:t>• Product = 42</a:t>
+            </a:r>
+            <a:br/>
+            <a:r>
+              <a:t>• Large 16MB window</a:t>
+            </a:r>
+            <a:br/>
+            <a:br/>
+            <a:r>
+              <a:t>[MAIN RAM]</a:t>
+            </a:r>
+            <a:br/>
+            <a:r>
+              <a:t>• Program variables</a:t>
+            </a:r>
+            <a:br/>
+            <a:br/>
+            <a:r>
+              <a:t>[PERIPHERALS]</a:t>
+            </a:r>
+            <a:br/>
+            <a:r>
+              <a:t>• Timers, UART, GPIO</a:t>
             </a:r>
           </a:p>
         </p:txBody>
@@ -4164,7 +4216,7 @@
               </a:defRPr>
             </a:pPr>
             <a:r>
-              <a:t>1. External Serial &amp; Debug Streams</a:t>
+              <a:t>1. External Serial Port</a:t>
             </a:r>
           </a:p>
           <a:p>
@@ -4179,7 +4231,7 @@
               </a:defRPr>
             </a:pPr>
             <a:r>
-              <a:t>• UARTSin / UARTSout (1-bit):</a:t>
+              <a:t>• uart_rx (1-bit):</a:t>
             </a:r>
           </a:p>
           <a:p>
@@ -4191,7 +4243,7 @@
               </a:defRPr>
             </a:pPr>
             <a:r>
-              <a:t>  Shared physical pins into Uncore 16550 UART</a:t>
+              <a:t>  Input from PC TX pin (commands arrive here)</a:t>
             </a:r>
           </a:p>
           <a:p>
@@ -4206,7 +4258,7 @@
               </a:defRPr>
             </a:pPr>
             <a:r>
-              <a:t>• dbg_uart_rx_* (Stream):</a:t>
+              <a:t>• uart_tx (1-bit):</a:t>
             </a:r>
           </a:p>
           <a:p>
@@ -4218,7 +4270,7 @@
               </a:defRPr>
             </a:pPr>
             <a:r>
-              <a:t>  Direct byte stream from Uncore UART to ADP</a:t>
+              <a:t>  Output to PC RX pin (responses sent back)</a:t>
             </a:r>
           </a:p>
           <a:p>
@@ -4233,7 +4285,7 @@
               </a:defRPr>
             </a:pPr>
             <a:r>
-              <a:t>• dbg_uart_tx_* (Stream):</a:t>
+              <a:t>• Speed:</a:t>
             </a:r>
           </a:p>
           <a:p>
@@ -4245,7 +4297,7 @@
               </a:defRPr>
             </a:pPr>
             <a:r>
-              <a:t>  Response stream from ADP to Uncore UART</a:t>
+              <a:t>  115,200 baud (standard serial speed)</a:t>
             </a:r>
           </a:p>
           <a:p>
@@ -4260,7 +4312,7 @@
               </a:defRPr>
             </a:pPr>
             <a:r>
-              <a:t>• Zero Duplication:</a:t>
+              <a:t>• Physical:</a:t>
             </a:r>
           </a:p>
           <a:p>
@@ -4272,7 +4324,7 @@
               </a:defRPr>
             </a:pPr>
             <a:r>
-              <a:t>  Reuses existing UART; only 2 pins for entire SoC!</a:t>
+              <a:t>  Only 2 pins needed on the entire FPGA/ASIC!</a:t>
             </a:r>
           </a:p>
         </p:txBody>
@@ -6147,6 +6199,7 @@
             </a:r>
           </a:p>
           <a:p>
+            <a:br/>
             <a:pPr>
               <a:defRPr sz="1100">
                 <a:solidFill>
@@ -6155,7 +6208,12 @@
               </a:defRPr>
             </a:pPr>
             <a:r>
-              <a:t> You send 6 text characters over serial terminal. Uncore 16550 UART receives bytes via UARTSin and streams them to the ADP engine.</a:t>
+              <a:t>You send 6 text characters over serial terminal.</a:t>
+            </a:r>
+            <a:br/>
+            <a:br/>
+            <a:r>
+              <a:t>socdebug_uart translates serial bits into byte stream.</a:t>
             </a:r>
           </a:p>
         </p:txBody>
@@ -6897,6 +6955,7 @@
             </a:r>
           </a:p>
           <a:p>
+            <a:br/>
             <a:pPr>
               <a:defRPr sz="1100">
                 <a:solidFill>
@@ -6905,11 +6964,16 @@
               </a:defRPr>
             </a:pPr>
             <a:r>
-              <a:t> Debugger formats the result into text: 'R 0x0000002A</a:t>
+              <a:t>Debugger formats the result into text:</a:t>
             </a:r>
             <a:br/>
             <a:r>
-              <a:t>]' and streams it through the Uncore UART out over UARTSout to your PC terminal: 42 (0x2A)!</a:t>
+              <a:t>'R 0x0000002A\n]'</a:t>
+            </a:r>
+            <a:br/>
+            <a:br/>
+            <a:r>
+              <a:t>Your terminal shows: 42 (0x2A)!</a:t>
             </a:r>
           </a:p>
         </p:txBody>

</xml_diff>